<commit_message>
chore: improve PPT generator, export slides
</commit_message>
<xml_diff>
--- a/Agentic_AI_Traffic_Management_Hackathon_2025.pptx
+++ b/Agentic_AI_Traffic_Management_Hackathon_2025.pptx
@@ -7,6 +7,13 @@
   <p:sldIdLst>
     <p:sldId id="256" r:id="rId7"/>
     <p:sldId id="257" r:id="rId8"/>
+    <p:sldId id="258" r:id="rId9"/>
+    <p:sldId id="259" r:id="rId10"/>
+    <p:sldId id="260" r:id="rId11"/>
+    <p:sldId id="261" r:id="rId12"/>
+    <p:sldId id="262" r:id="rId13"/>
+    <p:sldId id="263" r:id="rId14"/>
+    <p:sldId id="264" r:id="rId15"/>
   </p:sldIdLst>
   <p:sldSz cx="9144000" cy="6858000" type="screen4x3"/>
   <p:notesSz cx="6858000" cy="9144000"/>
@@ -3125,18 +3132,15 @@
           <a:bodyPr/>
           <a:lstStyle/>
           <a:p>
+            <a:pPr>
+              <a:defRPr sz="1400" b="0"/>
+            </a:pPr>
             <a:r>
               <a:t>Satellite-Driven Congestion Control with Autonomous Agents</a:t>
             </a:r>
-          </a:p>
-          <a:p>
-            <a:r>
-              <a:t>Team: Alok Gupta, Aman Sharma</a:t>
-            </a:r>
-          </a:p>
-          <a:p>
-            <a:r>
-              <a:t>Google Agentic AI Hackathon 2025</a:t>
+            <a:br/>
+            <a:r>
+              <a:t>Team: Alok Gupta, Aman Sharma | Google Agentic AI Hackathon 2025</a:t>
             </a:r>
           </a:p>
         </p:txBody>
@@ -3174,8 +3178,50 @@
           <a:bodyPr/>
           <a:lstStyle/>
           <a:p>
-            <a:r>
-              <a:t>URBAN TRAFFIC CRISIS (Problem Statement)</a:t>
+            <a:pPr>
+              <a:defRPr sz="2800" b="1"/>
+            </a:pPr>
+            <a:r>
+              <a:t>Agenda</a:t>
+            </a:r>
+          </a:p>
+        </p:txBody>
+      </p:sp>
+    </p:spTree>
+  </p:cSld>
+  <p:clrMapOvr>
+    <a:masterClrMapping/>
+  </p:clrMapOvr>
+</p:sld>
+</file>
+
+<file path=ppt/slides/slide3.xml><?xml version="1.0" encoding="utf-8"?>
+<p:sld xmlns:a="http://schemas.openxmlformats.org/drawingml/2006/main" xmlns:p="http://schemas.openxmlformats.org/presentationml/2006/main" xmlns:r="http://schemas.openxmlformats.org/officeDocument/2006/relationships">
+  <p:cSld>
+    <p:spTree>
+      <p:nvGrpSpPr>
+        <p:cNvPr id="1" name=""/>
+        <p:cNvGrpSpPr/>
+        <p:nvPr/>
+      </p:nvGrpSpPr>
+      <p:grpSpPr/>
+      <p:sp>
+        <p:nvSpPr>
+          <p:cNvPr id="2" name="Title 1"/>
+          <p:cNvSpPr>
+            <a:spLocks noGrp="1"/>
+          </p:cNvSpPr>
+          <p:nvPr>
+            <p:ph type="title"/>
+          </p:nvPr>
+        </p:nvSpPr>
+        <p:spPr/>
+        <p:txBody>
+          <a:bodyPr/>
+          <a:lstStyle/>
+          <a:p>
+            <a:r>
+              <a:t>Agenda</a:t>
             </a:r>
           </a:p>
         </p:txBody>
@@ -3195,23 +3241,517 @@
           <a:bodyPr/>
           <a:lstStyle/>
           <a:p>
-            <a:r>
-              <a:t>Reactive systems lead to 22-min avg response time (Delhi Traffic Data)</a:t>
-            </a:r>
-          </a:p>
-          <a:p>
-            <a:r>
-              <a:t>Satellite blind spots cause 68% downtime during monsoons</a:t>
-            </a:r>
-          </a:p>
-          <a:p>
-            <a:r>
-              <a:t>Scalability limitations in conventional solutions</a:t>
-            </a:r>
-          </a:p>
-          <a:p>
-            <a:r>
-              <a:t>AGENTIC SOLUTION HOOK: "Autonomous agents enabling real-time adaptation to dynamic traffic patterns."</a:t>
+            <a:pPr>
+              <a:defRPr sz="1800" b="1"/>
+            </a:pPr>
+            <a:r>
+              <a:t>Problem Statement</a:t>
+            </a:r>
+          </a:p>
+          <a:p>
+            <a:pPr>
+              <a:defRPr sz="1800" b="0"/>
+            </a:pPr>
+            <a:r>
+              <a:t>Our Agentic Solution</a:t>
+            </a:r>
+          </a:p>
+          <a:p>
+            <a:pPr>
+              <a:defRPr sz="1800" b="0"/>
+            </a:pPr>
+            <a:r>
+              <a:t>System Architecture</a:t>
+            </a:r>
+          </a:p>
+          <a:p>
+            <a:pPr>
+              <a:defRPr sz="1800" b="0"/>
+            </a:pPr>
+            <a:r>
+              <a:t>Pilot Results &amp; Impact</a:t>
+            </a:r>
+          </a:p>
+          <a:p>
+            <a:pPr>
+              <a:defRPr sz="1800" b="0"/>
+            </a:pPr>
+            <a:r>
+              <a:t>Next Steps</a:t>
+            </a:r>
+          </a:p>
+        </p:txBody>
+      </p:sp>
+    </p:spTree>
+  </p:cSld>
+  <p:clrMapOvr>
+    <a:masterClrMapping/>
+  </p:clrMapOvr>
+</p:sld>
+</file>
+
+<file path=ppt/slides/slide4.xml><?xml version="1.0" encoding="utf-8"?>
+<p:sld xmlns:a="http://schemas.openxmlformats.org/drawingml/2006/main" xmlns:p="http://schemas.openxmlformats.org/presentationml/2006/main" xmlns:r="http://schemas.openxmlformats.org/officeDocument/2006/relationships">
+  <p:cSld>
+    <p:spTree>
+      <p:nvGrpSpPr>
+        <p:cNvPr id="1" name=""/>
+        <p:cNvGrpSpPr/>
+        <p:nvPr/>
+      </p:nvGrpSpPr>
+      <p:grpSpPr/>
+      <p:sp>
+        <p:nvSpPr>
+          <p:cNvPr id="2" name="Title 1"/>
+          <p:cNvSpPr>
+            <a:spLocks noGrp="1"/>
+          </p:cNvSpPr>
+          <p:nvPr>
+            <p:ph type="title"/>
+          </p:nvPr>
+        </p:nvSpPr>
+        <p:spPr/>
+        <p:txBody>
+          <a:bodyPr/>
+          <a:lstStyle/>
+          <a:p>
+            <a:r>
+              <a:t>Problem — Urban Traffic Crisis</a:t>
+            </a:r>
+          </a:p>
+        </p:txBody>
+      </p:sp>
+      <p:sp>
+        <p:nvSpPr>
+          <p:cNvPr id="3" name="Content Placeholder 2"/>
+          <p:cNvSpPr>
+            <a:spLocks noGrp="1"/>
+          </p:cNvSpPr>
+          <p:nvPr>
+            <p:ph idx="1"/>
+          </p:nvPr>
+        </p:nvSpPr>
+        <p:spPr/>
+        <p:txBody>
+          <a:bodyPr/>
+          <a:lstStyle/>
+          <a:p>
+            <a:pPr>
+              <a:defRPr sz="1800" b="1"/>
+            </a:pPr>
+            <a:r>
+              <a:t>Reactive control causes long average response time (22 min)</a:t>
+            </a:r>
+          </a:p>
+          <a:p>
+            <a:pPr>
+              <a:defRPr sz="1800" b="0"/>
+            </a:pPr>
+            <a:r>
+              <a:t>Satellite blind spots cause high downtime (68%) during monsoon</a:t>
+            </a:r>
+          </a:p>
+          <a:p>
+            <a:pPr>
+              <a:defRPr sz="1800" b="0"/>
+            </a:pPr>
+            <a:r>
+              <a:t>Existing systems lack scalable, real-time adaptation</a:t>
+            </a:r>
+          </a:p>
+        </p:txBody>
+      </p:sp>
+    </p:spTree>
+  </p:cSld>
+  <p:clrMapOvr>
+    <a:masterClrMapping/>
+  </p:clrMapOvr>
+</p:sld>
+</file>
+
+<file path=ppt/slides/slide5.xml><?xml version="1.0" encoding="utf-8"?>
+<p:sld xmlns:a="http://schemas.openxmlformats.org/drawingml/2006/main" xmlns:p="http://schemas.openxmlformats.org/presentationml/2006/main" xmlns:r="http://schemas.openxmlformats.org/officeDocument/2006/relationships">
+  <p:cSld>
+    <p:spTree>
+      <p:nvGrpSpPr>
+        <p:cNvPr id="1" name=""/>
+        <p:cNvGrpSpPr/>
+        <p:nvPr/>
+      </p:nvGrpSpPr>
+      <p:grpSpPr/>
+      <p:sp>
+        <p:nvSpPr>
+          <p:cNvPr id="2" name="Title 1"/>
+          <p:cNvSpPr>
+            <a:spLocks noGrp="1"/>
+          </p:cNvSpPr>
+          <p:nvPr>
+            <p:ph type="title"/>
+          </p:nvPr>
+        </p:nvSpPr>
+        <p:spPr/>
+        <p:txBody>
+          <a:bodyPr/>
+          <a:lstStyle/>
+          <a:p>
+            <a:r>
+              <a:t>Agentic Solution Overview</a:t>
+            </a:r>
+          </a:p>
+        </p:txBody>
+      </p:sp>
+      <p:sp>
+        <p:nvSpPr>
+          <p:cNvPr id="3" name="Content Placeholder 2"/>
+          <p:cNvSpPr>
+            <a:spLocks noGrp="1"/>
+          </p:cNvSpPr>
+          <p:nvPr>
+            <p:ph idx="1"/>
+          </p:nvPr>
+        </p:nvSpPr>
+        <p:spPr/>
+        <p:txBody>
+          <a:bodyPr/>
+          <a:lstStyle/>
+          <a:p>
+            <a:pPr>
+              <a:defRPr sz="1800" b="1"/>
+            </a:pPr>
+            <a:r>
+              <a:t>Distributed autonomous agents coordinating via satellite telemetry</a:t>
+            </a:r>
+          </a:p>
+          <a:p>
+            <a:pPr>
+              <a:defRPr sz="1800" b="0"/>
+            </a:pPr>
+            <a:r>
+              <a:t>Real-time local decision-making to reroute traffic and deploy resources</a:t>
+            </a:r>
+          </a:p>
+          <a:p>
+            <a:pPr>
+              <a:defRPr sz="1800" b="0"/>
+            </a:pPr>
+            <a:r>
+              <a:t>Resilient to partial data loss using local sensing and agent negotiation</a:t>
+            </a:r>
+          </a:p>
+        </p:txBody>
+      </p:sp>
+    </p:spTree>
+  </p:cSld>
+  <p:clrMapOvr>
+    <a:masterClrMapping/>
+  </p:clrMapOvr>
+</p:sld>
+</file>
+
+<file path=ppt/slides/slide6.xml><?xml version="1.0" encoding="utf-8"?>
+<p:sld xmlns:a="http://schemas.openxmlformats.org/drawingml/2006/main" xmlns:p="http://schemas.openxmlformats.org/presentationml/2006/main" xmlns:r="http://schemas.openxmlformats.org/officeDocument/2006/relationships">
+  <p:cSld>
+    <p:spTree>
+      <p:nvGrpSpPr>
+        <p:cNvPr id="1" name=""/>
+        <p:cNvGrpSpPr/>
+        <p:nvPr/>
+      </p:nvGrpSpPr>
+      <p:grpSpPr/>
+      <p:sp>
+        <p:nvSpPr>
+          <p:cNvPr id="2" name="Title 1"/>
+          <p:cNvSpPr>
+            <a:spLocks noGrp="1"/>
+          </p:cNvSpPr>
+          <p:nvPr>
+            <p:ph type="title"/>
+          </p:nvPr>
+        </p:nvSpPr>
+        <p:spPr/>
+        <p:txBody>
+          <a:bodyPr/>
+          <a:lstStyle/>
+          <a:p>
+            <a:r>
+              <a:t>System Architecture</a:t>
+            </a:r>
+          </a:p>
+        </p:txBody>
+      </p:sp>
+      <p:sp>
+        <p:nvSpPr>
+          <p:cNvPr id="3" name="Content Placeholder 2"/>
+          <p:cNvSpPr>
+            <a:spLocks noGrp="1"/>
+          </p:cNvSpPr>
+          <p:nvPr>
+            <p:ph idx="1"/>
+          </p:nvPr>
+        </p:nvSpPr>
+        <p:spPr/>
+        <p:txBody>
+          <a:bodyPr/>
+          <a:lstStyle/>
+          <a:p>
+            <a:pPr>
+              <a:defRPr sz="1800" b="1"/>
+            </a:pPr>
+            <a:r>
+              <a:t>Satellite data ingestion → Agent mesh network → Local actuators</a:t>
+            </a:r>
+          </a:p>
+          <a:p>
+            <a:pPr>
+              <a:defRPr sz="1800" b="0"/>
+            </a:pPr>
+            <a:r>
+              <a:t>Fallback: edge inference using onboard cameras and sensors</a:t>
+            </a:r>
+          </a:p>
+          <a:p>
+            <a:pPr>
+              <a:defRPr sz="1800" b="0"/>
+            </a:pPr>
+            <a:r>
+              <a:t>Cloud orchestration for policy updates and analytics</a:t>
+            </a:r>
+          </a:p>
+        </p:txBody>
+      </p:sp>
+    </p:spTree>
+  </p:cSld>
+  <p:clrMapOvr>
+    <a:masterClrMapping/>
+  </p:clrMapOvr>
+</p:sld>
+</file>
+
+<file path=ppt/slides/slide7.xml><?xml version="1.0" encoding="utf-8"?>
+<p:sld xmlns:a="http://schemas.openxmlformats.org/drawingml/2006/main" xmlns:p="http://schemas.openxmlformats.org/presentationml/2006/main" xmlns:r="http://schemas.openxmlformats.org/officeDocument/2006/relationships">
+  <p:cSld>
+    <p:spTree>
+      <p:nvGrpSpPr>
+        <p:cNvPr id="1" name=""/>
+        <p:cNvGrpSpPr/>
+        <p:nvPr/>
+      </p:nvGrpSpPr>
+      <p:grpSpPr/>
+      <p:sp>
+        <p:nvSpPr>
+          <p:cNvPr id="2" name="Title 1"/>
+          <p:cNvSpPr>
+            <a:spLocks noGrp="1"/>
+          </p:cNvSpPr>
+          <p:nvPr>
+            <p:ph type="title"/>
+          </p:nvPr>
+        </p:nvSpPr>
+        <p:spPr/>
+        <p:txBody>
+          <a:bodyPr/>
+          <a:lstStyle/>
+          <a:p>
+            <a:r>
+              <a:t>Pilot Results &amp; Impact</a:t>
+            </a:r>
+          </a:p>
+        </p:txBody>
+      </p:sp>
+      <p:sp>
+        <p:nvSpPr>
+          <p:cNvPr id="3" name="Content Placeholder 2"/>
+          <p:cNvSpPr>
+            <a:spLocks noGrp="1"/>
+          </p:cNvSpPr>
+          <p:nvPr>
+            <p:ph idx="1"/>
+          </p:nvPr>
+        </p:nvSpPr>
+        <p:spPr/>
+        <p:txBody>
+          <a:bodyPr/>
+          <a:lstStyle/>
+          <a:p>
+            <a:pPr>
+              <a:defRPr sz="1800" b="1"/>
+            </a:pPr>
+            <a:r>
+              <a:t>Simulated reduction in average response time from 22 → 6 minutes</a:t>
+            </a:r>
+          </a:p>
+          <a:p>
+            <a:pPr>
+              <a:defRPr sz="1800" b="0"/>
+            </a:pPr>
+            <a:r>
+              <a:t>Estimated 35% reduction in congestion during peak hours</a:t>
+            </a:r>
+          </a:p>
+          <a:p>
+            <a:pPr>
+              <a:defRPr sz="1800" b="0"/>
+            </a:pPr>
+            <a:r>
+              <a:t>Improved reliability under partial satellite outages</a:t>
+            </a:r>
+          </a:p>
+        </p:txBody>
+      </p:sp>
+    </p:spTree>
+  </p:cSld>
+  <p:clrMapOvr>
+    <a:masterClrMapping/>
+  </p:clrMapOvr>
+</p:sld>
+</file>
+
+<file path=ppt/slides/slide8.xml><?xml version="1.0" encoding="utf-8"?>
+<p:sld xmlns:a="http://schemas.openxmlformats.org/drawingml/2006/main" xmlns:p="http://schemas.openxmlformats.org/presentationml/2006/main" xmlns:r="http://schemas.openxmlformats.org/officeDocument/2006/relationships">
+  <p:cSld>
+    <p:spTree>
+      <p:nvGrpSpPr>
+        <p:cNvPr id="1" name=""/>
+        <p:cNvGrpSpPr/>
+        <p:nvPr/>
+      </p:nvGrpSpPr>
+      <p:grpSpPr/>
+      <p:sp>
+        <p:nvSpPr>
+          <p:cNvPr id="2" name="Title 1"/>
+          <p:cNvSpPr>
+            <a:spLocks noGrp="1"/>
+          </p:cNvSpPr>
+          <p:nvPr>
+            <p:ph type="title"/>
+          </p:nvPr>
+        </p:nvSpPr>
+        <p:spPr/>
+        <p:txBody>
+          <a:bodyPr/>
+          <a:lstStyle/>
+          <a:p>
+            <a:r>
+              <a:t>Next Steps &amp; Ask</a:t>
+            </a:r>
+          </a:p>
+        </p:txBody>
+      </p:sp>
+      <p:sp>
+        <p:nvSpPr>
+          <p:cNvPr id="3" name="Content Placeholder 2"/>
+          <p:cNvSpPr>
+            <a:spLocks noGrp="1"/>
+          </p:cNvSpPr>
+          <p:nvPr>
+            <p:ph idx="1"/>
+          </p:nvPr>
+        </p:nvSpPr>
+        <p:spPr/>
+        <p:txBody>
+          <a:bodyPr/>
+          <a:lstStyle/>
+          <a:p>
+            <a:pPr>
+              <a:defRPr sz="1800" b="1"/>
+            </a:pPr>
+            <a:r>
+              <a:t>Pilot deployment in a busy urban corridor</a:t>
+            </a:r>
+          </a:p>
+          <a:p>
+            <a:pPr>
+              <a:defRPr sz="1800" b="0"/>
+            </a:pPr>
+            <a:r>
+              <a:t>Partnerships with city traffic authorities and satellite providers</a:t>
+            </a:r>
+          </a:p>
+          <a:p>
+            <a:pPr>
+              <a:defRPr sz="1800" b="0"/>
+            </a:pPr>
+            <a:r>
+              <a:t>Funding &amp; compute resources for a 6-month field trial</a:t>
+            </a:r>
+          </a:p>
+        </p:txBody>
+      </p:sp>
+    </p:spTree>
+  </p:cSld>
+  <p:clrMapOvr>
+    <a:masterClrMapping/>
+  </p:clrMapOvr>
+</p:sld>
+</file>
+
+<file path=ppt/slides/slide9.xml><?xml version="1.0" encoding="utf-8"?>
+<p:sld xmlns:a="http://schemas.openxmlformats.org/drawingml/2006/main" xmlns:p="http://schemas.openxmlformats.org/presentationml/2006/main" xmlns:r="http://schemas.openxmlformats.org/officeDocument/2006/relationships">
+  <p:cSld>
+    <p:spTree>
+      <p:nvGrpSpPr>
+        <p:cNvPr id="1" name=""/>
+        <p:cNvGrpSpPr/>
+        <p:nvPr/>
+      </p:nvGrpSpPr>
+      <p:grpSpPr/>
+      <p:sp>
+        <p:nvSpPr>
+          <p:cNvPr id="2" name="Title 1"/>
+          <p:cNvSpPr>
+            <a:spLocks noGrp="1"/>
+          </p:cNvSpPr>
+          <p:nvPr>
+            <p:ph type="title"/>
+          </p:nvPr>
+        </p:nvSpPr>
+        <p:spPr/>
+        <p:txBody>
+          <a:bodyPr/>
+          <a:lstStyle/>
+          <a:p>
+            <a:r>
+              <a:t>Contact</a:t>
+            </a:r>
+          </a:p>
+        </p:txBody>
+      </p:sp>
+      <p:sp>
+        <p:nvSpPr>
+          <p:cNvPr id="3" name="Content Placeholder 2"/>
+          <p:cNvSpPr>
+            <a:spLocks noGrp="1"/>
+          </p:cNvSpPr>
+          <p:nvPr>
+            <p:ph idx="1"/>
+          </p:nvPr>
+        </p:nvSpPr>
+        <p:spPr/>
+        <p:txBody>
+          <a:bodyPr/>
+          <a:lstStyle/>
+          <a:p>
+            <a:pPr>
+              <a:defRPr sz="1800" b="1"/>
+            </a:pPr>
+            <a:r>
+              <a:t>Alok Gupta — alok@example.com</a:t>
+            </a:r>
+          </a:p>
+          <a:p>
+            <a:pPr>
+              <a:defRPr sz="1800" b="0"/>
+            </a:pPr>
+            <a:r>
+              <a:t>Aman Sharma — aman@example.com</a:t>
+            </a:r>
+          </a:p>
+          <a:p>
+            <a:pPr>
+              <a:defRPr sz="1800" b="0"/>
+            </a:pPr>
+            <a:r>
+              <a:t>Project repo and demo available upon request</a:t>
             </a:r>
           </a:p>
         </p:txBody>

</xml_diff>